<commit_message>
Docs: precise wording — only taxonomy & risk are NCBI-grounded
Correct the over-generalized "6 nodes become NCBI-grounded LLM agents". Only
taxonomy and risk query verified NCBI Taxonomy live (by taxid); the other four
LLM nodes (qc/abundance/novel_virus/narrative) use a curated reference. Updated
summary-MetaMAVS.md and the detailed summary deck.

Co-Authored-By: Claude Fable 5 <noreply@anthropic.com>
</commit_message>
<xml_diff>
--- a/summary-MetaMAVS.pptx
+++ b/summary-MetaMAVS.pptx
@@ -33944,7 +33944,36 @@
                 <a:ea typeface="Calibri" pitchFamily="34" charset="-122"/>
                 <a:cs typeface="Calibri" pitchFamily="34" charset="-120"/>
               </a:rPr>
-              <a:t>• 6 nodes become NCBI-grounded LLM agents when enabled</a:t>
+              <a:t>• 6 nodes optionally become LLM agents when enabled</a:t>
+            </a:r>
+            <a:endParaRPr lang="en-US" sz="1080" dirty="0"/>
+          </a:p>
+          <a:p>
+            <a:pPr indent="0" marL="0">
+              <a:lnSpc>
+                <a:spcPct val="106000"/>
+              </a:lnSpc>
+              <a:buNone/>
+            </a:pPr>
+            <a:endParaRPr lang="en-US" sz="1080" dirty="0"/>
+          </a:p>
+          <a:p>
+            <a:pPr indent="0" marL="0">
+              <a:lnSpc>
+                <a:spcPct val="106000"/>
+              </a:lnSpc>
+              <a:buNone/>
+            </a:pPr>
+            <a:r>
+              <a:rPr lang="en-US" sz="1080" dirty="0">
+                <a:solidFill>
+                  <a:srgbClr val="6B7A8D"/>
+                </a:solidFill>
+                <a:latin typeface="Calibri" pitchFamily="34" charset="0"/>
+                <a:ea typeface="Calibri" pitchFamily="34" charset="-122"/>
+                <a:cs typeface="Calibri" pitchFamily="34" charset="-120"/>
+              </a:rPr>
+              <a:t>• taxonomy &amp; risk grounded in verified NCBI Taxonomy; others use a curated reference</a:t>
             </a:r>
             <a:endParaRPr lang="en-US" sz="1080" dirty="0"/>
           </a:p>

</xml_diff>